<commit_message>
Update the presentation files
</commit_message>
<xml_diff>
--- a/Activities/Presentations/Lab 2.pptx
+++ b/Activities/Presentations/Lab 2.pptx
@@ -6,16 +6,15 @@
   </p:sldMasterIdLst>
   <p:sldIdLst>
     <p:sldId id="256" r:id="rId2"/>
-    <p:sldId id="262" r:id="rId3"/>
-    <p:sldId id="263" r:id="rId4"/>
-    <p:sldId id="264" r:id="rId5"/>
-    <p:sldId id="257" r:id="rId6"/>
-    <p:sldId id="267" r:id="rId7"/>
-    <p:sldId id="259" r:id="rId8"/>
-    <p:sldId id="265" r:id="rId9"/>
-    <p:sldId id="266" r:id="rId10"/>
-    <p:sldId id="260" r:id="rId11"/>
-    <p:sldId id="268" r:id="rId12"/>
+    <p:sldId id="263" r:id="rId3"/>
+    <p:sldId id="264" r:id="rId4"/>
+    <p:sldId id="257" r:id="rId5"/>
+    <p:sldId id="267" r:id="rId6"/>
+    <p:sldId id="259" r:id="rId7"/>
+    <p:sldId id="265" r:id="rId8"/>
+    <p:sldId id="266" r:id="rId9"/>
+    <p:sldId id="260" r:id="rId10"/>
+    <p:sldId id="268" r:id="rId11"/>
   </p:sldIdLst>
   <p:sldSz cx="9144000" cy="6858000" type="screen4x3"/>
   <p:notesSz cx="6858000" cy="9144000"/>
@@ -114,6 +113,22 @@
       </a:defRPr>
     </a:lvl9pPr>
   </p:defaultTextStyle>
+  <p:extLst>
+    <p:ext uri="{EFAFB233-063F-42B5-8137-9DF3F51BA10A}">
+      <p15:sldGuideLst xmlns:p15="http://schemas.microsoft.com/office/powerpoint/2012/main">
+        <p15:guide id="1" orient="horz" pos="2160">
+          <p15:clr>
+            <a:srgbClr val="A4A3A4"/>
+          </p15:clr>
+        </p15:guide>
+        <p15:guide id="2" pos="2880">
+          <p15:clr>
+            <a:srgbClr val="A4A3A4"/>
+          </p15:clr>
+        </p15:guide>
+      </p15:sldGuideLst>
+    </p:ext>
+  </p:extLst>
 </p:presentation>
 </file>
 
@@ -155,10 +170,9 @@
           <a:lstStyle/>
           <a:p>
             <a:r>
-              <a:rPr lang="en-US" smtClean="0"/>
+              <a:rPr lang="en-US"/>
               <a:t>Click to edit Master title style</a:t>
             </a:r>
-            <a:endParaRPr lang="en-US"/>
           </a:p>
         </p:txBody>
       </p:sp>
@@ -274,10 +288,9 @@
           </a:lstStyle>
           <a:p>
             <a:r>
-              <a:rPr lang="en-US" smtClean="0"/>
+              <a:rPr lang="en-US"/>
               <a:t>Click to edit Master subtitle style</a:t>
             </a:r>
-            <a:endParaRPr lang="en-US"/>
           </a:p>
         </p:txBody>
       </p:sp>
@@ -298,7 +311,7 @@
           <a:p>
             <a:fld id="{65692351-DC79-477B-9F1A-5335BAFBA9C2}" type="datetimeFigureOut">
               <a:rPr lang="en-US" smtClean="0"/>
-              <a:t>6/1/2020</a:t>
+              <a:t>8/1/2020</a:t>
             </a:fld>
             <a:endParaRPr lang="en-US"/>
           </a:p>
@@ -392,10 +405,9 @@
           <a:lstStyle/>
           <a:p>
             <a:r>
-              <a:rPr lang="en-US" smtClean="0"/>
+              <a:rPr lang="en-US"/>
               <a:t>Click to edit Master title style</a:t>
             </a:r>
-            <a:endParaRPr lang="en-US"/>
           </a:p>
         </p:txBody>
       </p:sp>
@@ -416,38 +428,37 @@
           <a:p>
             <a:pPr lvl="0"/>
             <a:r>
-              <a:rPr lang="en-US" smtClean="0"/>
+              <a:rPr lang="en-US"/>
               <a:t>Click to edit Master text styles</a:t>
             </a:r>
           </a:p>
           <a:p>
             <a:pPr lvl="1"/>
             <a:r>
-              <a:rPr lang="en-US" smtClean="0"/>
+              <a:rPr lang="en-US"/>
               <a:t>Second level</a:t>
             </a:r>
           </a:p>
           <a:p>
             <a:pPr lvl="2"/>
             <a:r>
-              <a:rPr lang="en-US" smtClean="0"/>
+              <a:rPr lang="en-US"/>
               <a:t>Third level</a:t>
             </a:r>
           </a:p>
           <a:p>
             <a:pPr lvl="3"/>
             <a:r>
-              <a:rPr lang="en-US" smtClean="0"/>
+              <a:rPr lang="en-US"/>
               <a:t>Fourth level</a:t>
             </a:r>
           </a:p>
           <a:p>
             <a:pPr lvl="4"/>
             <a:r>
-              <a:rPr lang="en-US" smtClean="0"/>
+              <a:rPr lang="en-US"/>
               <a:t>Fifth level</a:t>
             </a:r>
-            <a:endParaRPr lang="en-US"/>
           </a:p>
         </p:txBody>
       </p:sp>
@@ -468,7 +479,7 @@
           <a:p>
             <a:fld id="{65692351-DC79-477B-9F1A-5335BAFBA9C2}" type="datetimeFigureOut">
               <a:rPr lang="en-US" smtClean="0"/>
-              <a:t>6/1/2020</a:t>
+              <a:t>8/1/2020</a:t>
             </a:fld>
             <a:endParaRPr lang="en-US"/>
           </a:p>
@@ -567,10 +578,9 @@
           <a:lstStyle/>
           <a:p>
             <a:r>
-              <a:rPr lang="en-US" smtClean="0"/>
+              <a:rPr lang="en-US"/>
               <a:t>Click to edit Master title style</a:t>
             </a:r>
-            <a:endParaRPr lang="en-US"/>
           </a:p>
         </p:txBody>
       </p:sp>
@@ -596,38 +606,37 @@
           <a:p>
             <a:pPr lvl="0"/>
             <a:r>
-              <a:rPr lang="en-US" smtClean="0"/>
+              <a:rPr lang="en-US"/>
               <a:t>Click to edit Master text styles</a:t>
             </a:r>
           </a:p>
           <a:p>
             <a:pPr lvl="1"/>
             <a:r>
-              <a:rPr lang="en-US" smtClean="0"/>
+              <a:rPr lang="en-US"/>
               <a:t>Second level</a:t>
             </a:r>
           </a:p>
           <a:p>
             <a:pPr lvl="2"/>
             <a:r>
-              <a:rPr lang="en-US" smtClean="0"/>
+              <a:rPr lang="en-US"/>
               <a:t>Third level</a:t>
             </a:r>
           </a:p>
           <a:p>
             <a:pPr lvl="3"/>
             <a:r>
-              <a:rPr lang="en-US" smtClean="0"/>
+              <a:rPr lang="en-US"/>
               <a:t>Fourth level</a:t>
             </a:r>
           </a:p>
           <a:p>
             <a:pPr lvl="4"/>
             <a:r>
-              <a:rPr lang="en-US" smtClean="0"/>
+              <a:rPr lang="en-US"/>
               <a:t>Fifth level</a:t>
             </a:r>
-            <a:endParaRPr lang="en-US"/>
           </a:p>
         </p:txBody>
       </p:sp>
@@ -648,7 +657,7 @@
           <a:p>
             <a:fld id="{65692351-DC79-477B-9F1A-5335BAFBA9C2}" type="datetimeFigureOut">
               <a:rPr lang="en-US" smtClean="0"/>
-              <a:t>6/1/2020</a:t>
+              <a:t>8/1/2020</a:t>
             </a:fld>
             <a:endParaRPr lang="en-US"/>
           </a:p>
@@ -742,10 +751,9 @@
           <a:lstStyle/>
           <a:p>
             <a:r>
-              <a:rPr lang="en-US" smtClean="0"/>
+              <a:rPr lang="en-US"/>
               <a:t>Click to edit Master title style</a:t>
             </a:r>
-            <a:endParaRPr lang="en-US"/>
           </a:p>
         </p:txBody>
       </p:sp>
@@ -766,38 +774,37 @@
           <a:p>
             <a:pPr lvl="0"/>
             <a:r>
-              <a:rPr lang="en-US" smtClean="0"/>
+              <a:rPr lang="en-US"/>
               <a:t>Click to edit Master text styles</a:t>
             </a:r>
           </a:p>
           <a:p>
             <a:pPr lvl="1"/>
             <a:r>
-              <a:rPr lang="en-US" smtClean="0"/>
+              <a:rPr lang="en-US"/>
               <a:t>Second level</a:t>
             </a:r>
           </a:p>
           <a:p>
             <a:pPr lvl="2"/>
             <a:r>
-              <a:rPr lang="en-US" smtClean="0"/>
+              <a:rPr lang="en-US"/>
               <a:t>Third level</a:t>
             </a:r>
           </a:p>
           <a:p>
             <a:pPr lvl="3"/>
             <a:r>
-              <a:rPr lang="en-US" smtClean="0"/>
+              <a:rPr lang="en-US"/>
               <a:t>Fourth level</a:t>
             </a:r>
           </a:p>
           <a:p>
             <a:pPr lvl="4"/>
             <a:r>
-              <a:rPr lang="en-US" smtClean="0"/>
+              <a:rPr lang="en-US"/>
               <a:t>Fifth level</a:t>
             </a:r>
-            <a:endParaRPr lang="en-US"/>
           </a:p>
         </p:txBody>
       </p:sp>
@@ -818,7 +825,7 @@
           <a:p>
             <a:fld id="{65692351-DC79-477B-9F1A-5335BAFBA9C2}" type="datetimeFigureOut">
               <a:rPr lang="en-US" smtClean="0"/>
-              <a:t>6/1/2020</a:t>
+              <a:t>8/1/2020</a:t>
             </a:fld>
             <a:endParaRPr lang="en-US"/>
           </a:p>
@@ -921,10 +928,9 @@
           </a:lstStyle>
           <a:p>
             <a:r>
-              <a:rPr lang="en-US" smtClean="0"/>
+              <a:rPr lang="en-US"/>
               <a:t>Click to edit Master title style</a:t>
             </a:r>
-            <a:endParaRPr lang="en-US"/>
           </a:p>
         </p:txBody>
       </p:sp>
@@ -1041,7 +1047,7 @@
           <a:p>
             <a:pPr lvl="0"/>
             <a:r>
-              <a:rPr lang="en-US" smtClean="0"/>
+              <a:rPr lang="en-US"/>
               <a:t>Click to edit Master text styles</a:t>
             </a:r>
           </a:p>
@@ -1064,7 +1070,7 @@
           <a:p>
             <a:fld id="{65692351-DC79-477B-9F1A-5335BAFBA9C2}" type="datetimeFigureOut">
               <a:rPr lang="en-US" smtClean="0"/>
-              <a:t>6/1/2020</a:t>
+              <a:t>8/1/2020</a:t>
             </a:fld>
             <a:endParaRPr lang="en-US"/>
           </a:p>
@@ -1158,10 +1164,9 @@
           <a:lstStyle/>
           <a:p>
             <a:r>
-              <a:rPr lang="en-US" smtClean="0"/>
+              <a:rPr lang="en-US"/>
               <a:t>Click to edit Master title style</a:t>
             </a:r>
-            <a:endParaRPr lang="en-US"/>
           </a:p>
         </p:txBody>
       </p:sp>
@@ -1215,38 +1220,37 @@
           <a:p>
             <a:pPr lvl="0"/>
             <a:r>
-              <a:rPr lang="en-US" smtClean="0"/>
+              <a:rPr lang="en-US"/>
               <a:t>Click to edit Master text styles</a:t>
             </a:r>
           </a:p>
           <a:p>
             <a:pPr lvl="1"/>
             <a:r>
-              <a:rPr lang="en-US" smtClean="0"/>
+              <a:rPr lang="en-US"/>
               <a:t>Second level</a:t>
             </a:r>
           </a:p>
           <a:p>
             <a:pPr lvl="2"/>
             <a:r>
-              <a:rPr lang="en-US" smtClean="0"/>
+              <a:rPr lang="en-US"/>
               <a:t>Third level</a:t>
             </a:r>
           </a:p>
           <a:p>
             <a:pPr lvl="3"/>
             <a:r>
-              <a:rPr lang="en-US" smtClean="0"/>
+              <a:rPr lang="en-US"/>
               <a:t>Fourth level</a:t>
             </a:r>
           </a:p>
           <a:p>
             <a:pPr lvl="4"/>
             <a:r>
-              <a:rPr lang="en-US" smtClean="0"/>
+              <a:rPr lang="en-US"/>
               <a:t>Fifth level</a:t>
             </a:r>
-            <a:endParaRPr lang="en-US"/>
           </a:p>
         </p:txBody>
       </p:sp>
@@ -1300,38 +1304,37 @@
           <a:p>
             <a:pPr lvl="0"/>
             <a:r>
-              <a:rPr lang="en-US" smtClean="0"/>
+              <a:rPr lang="en-US"/>
               <a:t>Click to edit Master text styles</a:t>
             </a:r>
           </a:p>
           <a:p>
             <a:pPr lvl="1"/>
             <a:r>
-              <a:rPr lang="en-US" smtClean="0"/>
+              <a:rPr lang="en-US"/>
               <a:t>Second level</a:t>
             </a:r>
           </a:p>
           <a:p>
             <a:pPr lvl="2"/>
             <a:r>
-              <a:rPr lang="en-US" smtClean="0"/>
+              <a:rPr lang="en-US"/>
               <a:t>Third level</a:t>
             </a:r>
           </a:p>
           <a:p>
             <a:pPr lvl="3"/>
             <a:r>
-              <a:rPr lang="en-US" smtClean="0"/>
+              <a:rPr lang="en-US"/>
               <a:t>Fourth level</a:t>
             </a:r>
           </a:p>
           <a:p>
             <a:pPr lvl="4"/>
             <a:r>
-              <a:rPr lang="en-US" smtClean="0"/>
+              <a:rPr lang="en-US"/>
               <a:t>Fifth level</a:t>
             </a:r>
-            <a:endParaRPr lang="en-US"/>
           </a:p>
         </p:txBody>
       </p:sp>
@@ -1352,7 +1355,7 @@
           <a:p>
             <a:fld id="{65692351-DC79-477B-9F1A-5335BAFBA9C2}" type="datetimeFigureOut">
               <a:rPr lang="en-US" smtClean="0"/>
-              <a:t>6/1/2020</a:t>
+              <a:t>8/1/2020</a:t>
             </a:fld>
             <a:endParaRPr lang="en-US"/>
           </a:p>
@@ -1450,10 +1453,9 @@
           </a:lstStyle>
           <a:p>
             <a:r>
-              <a:rPr lang="en-US" smtClean="0"/>
+              <a:rPr lang="en-US"/>
               <a:t>Click to edit Master title style</a:t>
             </a:r>
-            <a:endParaRPr lang="en-US"/>
           </a:p>
         </p:txBody>
       </p:sp>
@@ -1516,7 +1518,7 @@
           <a:p>
             <a:pPr lvl="0"/>
             <a:r>
-              <a:rPr lang="en-US" smtClean="0"/>
+              <a:rPr lang="en-US"/>
               <a:t>Click to edit Master text styles</a:t>
             </a:r>
           </a:p>
@@ -1572,38 +1574,37 @@
           <a:p>
             <a:pPr lvl="0"/>
             <a:r>
-              <a:rPr lang="en-US" smtClean="0"/>
+              <a:rPr lang="en-US"/>
               <a:t>Click to edit Master text styles</a:t>
             </a:r>
           </a:p>
           <a:p>
             <a:pPr lvl="1"/>
             <a:r>
-              <a:rPr lang="en-US" smtClean="0"/>
+              <a:rPr lang="en-US"/>
               <a:t>Second level</a:t>
             </a:r>
           </a:p>
           <a:p>
             <a:pPr lvl="2"/>
             <a:r>
-              <a:rPr lang="en-US" smtClean="0"/>
+              <a:rPr lang="en-US"/>
               <a:t>Third level</a:t>
             </a:r>
           </a:p>
           <a:p>
             <a:pPr lvl="3"/>
             <a:r>
-              <a:rPr lang="en-US" smtClean="0"/>
+              <a:rPr lang="en-US"/>
               <a:t>Fourth level</a:t>
             </a:r>
           </a:p>
           <a:p>
             <a:pPr lvl="4"/>
             <a:r>
-              <a:rPr lang="en-US" smtClean="0"/>
+              <a:rPr lang="en-US"/>
               <a:t>Fifth level</a:t>
             </a:r>
-            <a:endParaRPr lang="en-US"/>
           </a:p>
         </p:txBody>
       </p:sp>
@@ -1666,7 +1667,7 @@
           <a:p>
             <a:pPr lvl="0"/>
             <a:r>
-              <a:rPr lang="en-US" smtClean="0"/>
+              <a:rPr lang="en-US"/>
               <a:t>Click to edit Master text styles</a:t>
             </a:r>
           </a:p>
@@ -1722,38 +1723,37 @@
           <a:p>
             <a:pPr lvl="0"/>
             <a:r>
-              <a:rPr lang="en-US" smtClean="0"/>
+              <a:rPr lang="en-US"/>
               <a:t>Click to edit Master text styles</a:t>
             </a:r>
           </a:p>
           <a:p>
             <a:pPr lvl="1"/>
             <a:r>
-              <a:rPr lang="en-US" smtClean="0"/>
+              <a:rPr lang="en-US"/>
               <a:t>Second level</a:t>
             </a:r>
           </a:p>
           <a:p>
             <a:pPr lvl="2"/>
             <a:r>
-              <a:rPr lang="en-US" smtClean="0"/>
+              <a:rPr lang="en-US"/>
               <a:t>Third level</a:t>
             </a:r>
           </a:p>
           <a:p>
             <a:pPr lvl="3"/>
             <a:r>
-              <a:rPr lang="en-US" smtClean="0"/>
+              <a:rPr lang="en-US"/>
               <a:t>Fourth level</a:t>
             </a:r>
           </a:p>
           <a:p>
             <a:pPr lvl="4"/>
             <a:r>
-              <a:rPr lang="en-US" smtClean="0"/>
+              <a:rPr lang="en-US"/>
               <a:t>Fifth level</a:t>
             </a:r>
-            <a:endParaRPr lang="en-US"/>
           </a:p>
         </p:txBody>
       </p:sp>
@@ -1774,7 +1774,7 @@
           <a:p>
             <a:fld id="{65692351-DC79-477B-9F1A-5335BAFBA9C2}" type="datetimeFigureOut">
               <a:rPr lang="en-US" smtClean="0"/>
-              <a:t>6/1/2020</a:t>
+              <a:t>8/1/2020</a:t>
             </a:fld>
             <a:endParaRPr lang="en-US"/>
           </a:p>
@@ -1868,10 +1868,9 @@
           <a:lstStyle/>
           <a:p>
             <a:r>
-              <a:rPr lang="en-US" smtClean="0"/>
+              <a:rPr lang="en-US"/>
               <a:t>Click to edit Master title style</a:t>
             </a:r>
-            <a:endParaRPr lang="en-US"/>
           </a:p>
         </p:txBody>
       </p:sp>
@@ -1892,7 +1891,7 @@
           <a:p>
             <a:fld id="{65692351-DC79-477B-9F1A-5335BAFBA9C2}" type="datetimeFigureOut">
               <a:rPr lang="en-US" smtClean="0"/>
-              <a:t>6/1/2020</a:t>
+              <a:t>8/1/2020</a:t>
             </a:fld>
             <a:endParaRPr lang="en-US"/>
           </a:p>
@@ -1987,7 +1986,7 @@
           <a:p>
             <a:fld id="{65692351-DC79-477B-9F1A-5335BAFBA9C2}" type="datetimeFigureOut">
               <a:rPr lang="en-US" smtClean="0"/>
-              <a:t>6/1/2020</a:t>
+              <a:t>8/1/2020</a:t>
             </a:fld>
             <a:endParaRPr lang="en-US"/>
           </a:p>
@@ -2090,10 +2089,9 @@
           </a:lstStyle>
           <a:p>
             <a:r>
-              <a:rPr lang="en-US" smtClean="0"/>
+              <a:rPr lang="en-US"/>
               <a:t>Click to edit Master title style</a:t>
             </a:r>
-            <a:endParaRPr lang="en-US"/>
           </a:p>
         </p:txBody>
       </p:sp>
@@ -2147,38 +2145,37 @@
           <a:p>
             <a:pPr lvl="0"/>
             <a:r>
-              <a:rPr lang="en-US" smtClean="0"/>
+              <a:rPr lang="en-US"/>
               <a:t>Click to edit Master text styles</a:t>
             </a:r>
           </a:p>
           <a:p>
             <a:pPr lvl="1"/>
             <a:r>
-              <a:rPr lang="en-US" smtClean="0"/>
+              <a:rPr lang="en-US"/>
               <a:t>Second level</a:t>
             </a:r>
           </a:p>
           <a:p>
             <a:pPr lvl="2"/>
             <a:r>
-              <a:rPr lang="en-US" smtClean="0"/>
+              <a:rPr lang="en-US"/>
               <a:t>Third level</a:t>
             </a:r>
           </a:p>
           <a:p>
             <a:pPr lvl="3"/>
             <a:r>
-              <a:rPr lang="en-US" smtClean="0"/>
+              <a:rPr lang="en-US"/>
               <a:t>Fourth level</a:t>
             </a:r>
           </a:p>
           <a:p>
             <a:pPr lvl="4"/>
             <a:r>
-              <a:rPr lang="en-US" smtClean="0"/>
+              <a:rPr lang="en-US"/>
               <a:t>Fifth level</a:t>
             </a:r>
-            <a:endParaRPr lang="en-US"/>
           </a:p>
         </p:txBody>
       </p:sp>
@@ -2241,7 +2238,7 @@
           <a:p>
             <a:pPr lvl="0"/>
             <a:r>
-              <a:rPr lang="en-US" smtClean="0"/>
+              <a:rPr lang="en-US"/>
               <a:t>Click to edit Master text styles</a:t>
             </a:r>
           </a:p>
@@ -2264,7 +2261,7 @@
           <a:p>
             <a:fld id="{65692351-DC79-477B-9F1A-5335BAFBA9C2}" type="datetimeFigureOut">
               <a:rPr lang="en-US" smtClean="0"/>
-              <a:t>6/1/2020</a:t>
+              <a:t>8/1/2020</a:t>
             </a:fld>
             <a:endParaRPr lang="en-US"/>
           </a:p>
@@ -2367,10 +2364,9 @@
           </a:lstStyle>
           <a:p>
             <a:r>
-              <a:rPr lang="en-US" smtClean="0"/>
+              <a:rPr lang="en-US"/>
               <a:t>Click to edit Master title style</a:t>
             </a:r>
-            <a:endParaRPr lang="en-US"/>
           </a:p>
         </p:txBody>
       </p:sp>
@@ -2494,7 +2490,7 @@
           <a:p>
             <a:pPr lvl="0"/>
             <a:r>
-              <a:rPr lang="en-US" smtClean="0"/>
+              <a:rPr lang="en-US"/>
               <a:t>Click to edit Master text styles</a:t>
             </a:r>
           </a:p>
@@ -2517,7 +2513,7 @@
           <a:p>
             <a:fld id="{65692351-DC79-477B-9F1A-5335BAFBA9C2}" type="datetimeFigureOut">
               <a:rPr lang="en-US" smtClean="0"/>
-              <a:t>6/1/2020</a:t>
+              <a:t>8/1/2020</a:t>
             </a:fld>
             <a:endParaRPr lang="en-US"/>
           </a:p>
@@ -2626,10 +2622,9 @@
           <a:lstStyle/>
           <a:p>
             <a:r>
-              <a:rPr lang="en-US" smtClean="0"/>
+              <a:rPr lang="en-US"/>
               <a:t>Click to edit Master title style</a:t>
             </a:r>
-            <a:endParaRPr lang="en-US"/>
           </a:p>
         </p:txBody>
       </p:sp>
@@ -2660,38 +2655,37 @@
           <a:p>
             <a:pPr lvl="0"/>
             <a:r>
-              <a:rPr lang="en-US" smtClean="0"/>
+              <a:rPr lang="en-US"/>
               <a:t>Click to edit Master text styles</a:t>
             </a:r>
           </a:p>
           <a:p>
             <a:pPr lvl="1"/>
             <a:r>
-              <a:rPr lang="en-US" smtClean="0"/>
+              <a:rPr lang="en-US"/>
               <a:t>Second level</a:t>
             </a:r>
           </a:p>
           <a:p>
             <a:pPr lvl="2"/>
             <a:r>
-              <a:rPr lang="en-US" smtClean="0"/>
+              <a:rPr lang="en-US"/>
               <a:t>Third level</a:t>
             </a:r>
           </a:p>
           <a:p>
             <a:pPr lvl="3"/>
             <a:r>
-              <a:rPr lang="en-US" smtClean="0"/>
+              <a:rPr lang="en-US"/>
               <a:t>Fourth level</a:t>
             </a:r>
           </a:p>
           <a:p>
             <a:pPr lvl="4"/>
             <a:r>
-              <a:rPr lang="en-US" smtClean="0"/>
+              <a:rPr lang="en-US"/>
               <a:t>Fifth level</a:t>
             </a:r>
-            <a:endParaRPr lang="en-US"/>
           </a:p>
         </p:txBody>
       </p:sp>
@@ -2730,7 +2724,7 @@
           <a:p>
             <a:fld id="{65692351-DC79-477B-9F1A-5335BAFBA9C2}" type="datetimeFigureOut">
               <a:rPr lang="en-US" smtClean="0"/>
-              <a:t>6/1/2020</a:t>
+              <a:t>8/1/2020</a:t>
             </a:fld>
             <a:endParaRPr lang="en-US"/>
           </a:p>
@@ -3117,56 +3111,78 @@
         </p:nvSpPr>
         <p:spPr/>
         <p:txBody>
+          <a:bodyPr>
+            <a:noAutofit/>
+          </a:bodyPr>
+          <a:lstStyle/>
+          <a:p>
+            <a:r>
+              <a:rPr lang="en-US" sz="3200" dirty="0"/>
+              <a:t>First Order Plus Time Delay (FOPTD) Model</a:t>
+            </a:r>
+            <a:br>
+              <a:rPr lang="en-US" sz="3200" dirty="0"/>
+            </a:br>
+            <a:r>
+              <a:rPr lang="en-US" sz="3200" dirty="0"/>
+              <a:t>or</a:t>
+            </a:r>
+            <a:br>
+              <a:rPr lang="en-US" sz="3200" dirty="0"/>
+            </a:br>
+            <a:r>
+              <a:rPr lang="en-US" sz="3200" dirty="0"/>
+              <a:t>Time Delay Time Constant (TDTC) model</a:t>
+            </a:r>
+          </a:p>
+        </p:txBody>
+      </p:sp>
+      <p:sp>
+        <p:nvSpPr>
+          <p:cNvPr id="3" name="Subtitle 2">
+            <a:extLst>
+              <a:ext uri="{FF2B5EF4-FFF2-40B4-BE49-F238E27FC236}">
+                <a16:creationId xmlns:a16="http://schemas.microsoft.com/office/drawing/2014/main" id="{007D9BF7-E37C-4175-B9B9-027A47856F1E}"/>
+              </a:ext>
+            </a:extLst>
+          </p:cNvPr>
+          <p:cNvSpPr>
+            <a:spLocks noGrp="1"/>
+          </p:cNvSpPr>
+          <p:nvPr>
+            <p:ph type="subTitle" idx="1"/>
+          </p:nvPr>
+        </p:nvSpPr>
+        <p:spPr/>
+        <p:txBody>
           <a:bodyPr/>
           <a:lstStyle/>
           <a:p>
             <a:r>
-              <a:rPr lang="en-US" dirty="0" err="1" smtClean="0"/>
+              <a:rPr lang="en-US" dirty="0"/>
+              <a:t>ME</a:t>
+            </a:r>
+          </a:p>
+          <a:p>
+            <a:r>
+              <a:rPr lang="en-US" dirty="0" err="1"/>
               <a:t>Universitas</a:t>
             </a:r>
             <a:r>
-              <a:rPr lang="en-US" dirty="0" smtClean="0"/>
+              <a:rPr lang="en-US" dirty="0"/>
               <a:t> </a:t>
             </a:r>
             <a:r>
-              <a:rPr lang="en-US" dirty="0" err="1" smtClean="0"/>
-              <a:t>Pertamina’s</a:t>
-            </a:r>
-            <a:r>
-              <a:rPr lang="en-US" dirty="0" smtClean="0"/>
-              <a:t/>
-            </a:r>
-            <a:br>
-              <a:rPr lang="en-US" dirty="0" smtClean="0"/>
-            </a:br>
-            <a:r>
-              <a:rPr lang="en-US" dirty="0" smtClean="0"/>
-              <a:t>Temperature Control Lab</a:t>
+              <a:rPr lang="en-US" dirty="0" err="1"/>
+              <a:t>Pertamina</a:t>
             </a:r>
             <a:endParaRPr lang="en-US" dirty="0"/>
           </a:p>
-        </p:txBody>
-      </p:sp>
-      <p:sp>
-        <p:nvSpPr>
-          <p:cNvPr id="3" name="Subtitle 2"/>
-          <p:cNvSpPr>
-            <a:spLocks noGrp="1"/>
-          </p:cNvSpPr>
-          <p:nvPr>
-            <p:ph type="subTitle" idx="1"/>
-          </p:nvPr>
-        </p:nvSpPr>
-        <p:spPr/>
-        <p:txBody>
-          <a:bodyPr/>
-          <a:lstStyle/>
-          <a:p>
-            <a:r>
-              <a:rPr lang="en-US" dirty="0" smtClean="0"/>
-              <a:t>V2</a:t>
-            </a:r>
-            <a:endParaRPr lang="en-US" dirty="0"/>
+          <a:p>
+            <a:r>
+              <a:rPr lang="en-US" dirty="0"/>
+              <a:t>2020</a:t>
+            </a:r>
           </a:p>
         </p:txBody>
       </p:sp>
@@ -3180,13 +3196,6 @@
   <p:clrMapOvr>
     <a:masterClrMapping/>
   </p:clrMapOvr>
-  <p:timing>
-    <p:tnLst>
-      <p:par>
-        <p:cTn id="1" dur="indefinite" restart="never" nodeType="tmRoot"/>
-      </p:par>
-    </p:tnLst>
-  </p:timing>
 </p:sld>
 </file>
 
@@ -3209,7 +3218,13 @@
       </p:grpSpPr>
       <p:sp>
         <p:nvSpPr>
-          <p:cNvPr id="2" name="Title 1"/>
+          <p:cNvPr id="2" name="Title 1">
+            <a:extLst>
+              <a:ext uri="{FF2B5EF4-FFF2-40B4-BE49-F238E27FC236}">
+                <a16:creationId xmlns:a16="http://schemas.microsoft.com/office/drawing/2014/main" id="{D510C6E3-EFEA-49E7-A43B-00FEC4093C33}"/>
+              </a:ext>
+            </a:extLst>
+          </p:cNvPr>
           <p:cNvSpPr>
             <a:spLocks noGrp="1"/>
           </p:cNvSpPr>
@@ -3222,216 +3237,48 @@
           <a:bodyPr/>
           <a:lstStyle/>
           <a:p>
-            <a:r>
-              <a:rPr lang="en-US" dirty="0" smtClean="0"/>
-              <a:t>Results</a:t>
-            </a:r>
-            <a:endParaRPr lang="en-US" dirty="0"/>
-          </a:p>
-        </p:txBody>
-      </p:sp>
-      <p:pic>
-        <p:nvPicPr>
-          <p:cNvPr id="7170" name="Picture 2"/>
-          <p:cNvPicPr>
-            <a:picLocks noGrp="1" noChangeAspect="1" noChangeArrowheads="1"/>
-          </p:cNvPicPr>
-          <p:nvPr>
-            <p:ph idx="1"/>
-          </p:nvPr>
-        </p:nvPicPr>
-        <p:blipFill>
-          <a:blip r:embed="rId2">
+            <a:endParaRPr lang="en-US"/>
+          </a:p>
+        </p:txBody>
+      </p:sp>
+      <p:sp>
+        <p:nvSpPr>
+          <p:cNvPr id="3" name="Content Placeholder 2">
             <a:extLst>
-              <a:ext uri="{28A0092B-C50C-407E-A947-70E740481C1C}">
-                <a14:useLocalDpi xmlns:a14="http://schemas.microsoft.com/office/drawing/2010/main" val="0"/>
+              <a:ext uri="{FF2B5EF4-FFF2-40B4-BE49-F238E27FC236}">
+                <a16:creationId xmlns:a16="http://schemas.microsoft.com/office/drawing/2014/main" id="{86FF2DCB-F051-4AA9-9B00-E4757CDCFF13}"/>
               </a:ext>
             </a:extLst>
-          </a:blip>
-          <a:srcRect/>
-          <a:stretch>
-            <a:fillRect/>
-          </a:stretch>
-        </p:blipFill>
-        <p:spPr bwMode="auto">
-          <a:xfrm>
-            <a:off x="2095530" y="1600200"/>
-            <a:ext cx="4952940" cy="4525963"/>
-          </a:xfrm>
-          <a:prstGeom prst="rect">
-            <a:avLst/>
-          </a:prstGeom>
-          <a:noFill/>
-          <a:ln>
-            <a:noFill/>
-          </a:ln>
-          <a:effectLst/>
-          <a:extLst>
-            <a:ext uri="{909E8E84-426E-40DD-AFC4-6F175D3DCCD1}">
-              <a14:hiddenFill xmlns:a14="http://schemas.microsoft.com/office/drawing/2010/main">
-                <a:solidFill>
-                  <a:schemeClr val="accent1"/>
-                </a:solidFill>
-              </a14:hiddenFill>
-            </a:ext>
-            <a:ext uri="{91240B29-F687-4F45-9708-019B960494DF}">
-              <a14:hiddenLine xmlns:a14="http://schemas.microsoft.com/office/drawing/2010/main" w="9525">
-                <a:solidFill>
-                  <a:schemeClr val="tx1"/>
-                </a:solidFill>
-                <a:miter lim="800000"/>
-                <a:headEnd/>
-                <a:tailEnd/>
-              </a14:hiddenLine>
-            </a:ext>
-            <a:ext uri="{AF507438-7753-43E0-B8FC-AC1667EBCBE1}">
-              <a14:hiddenEffects xmlns:a14="http://schemas.microsoft.com/office/drawing/2010/main">
-                <a:effectLst>
-                  <a:outerShdw dist="35921" dir="2700000" algn="ctr" rotWithShape="0">
-                    <a:schemeClr val="bg2"/>
-                  </a:outerShdw>
-                </a:effectLst>
-              </a14:hiddenEffects>
-            </a:ext>
-          </a:extLst>
-        </p:spPr>
-      </p:pic>
+          </p:cNvPr>
+          <p:cNvSpPr>
+            <a:spLocks noGrp="1"/>
+          </p:cNvSpPr>
+          <p:nvPr>
+            <p:ph idx="1"/>
+          </p:nvPr>
+        </p:nvSpPr>
+        <p:spPr/>
+        <p:txBody>
+          <a:bodyPr/>
+          <a:lstStyle/>
+          <a:p>
+            <a:r>
+              <a:rPr lang="en-US" dirty="0"/>
+              <a:t>Calculate the absolute error (for every time point) and plot the error.</a:t>
+            </a:r>
+          </a:p>
+          <a:p>
+            <a:r>
+              <a:rPr lang="en-US" dirty="0"/>
+              <a:t>Can you also find the integral of the absolute error (the area under the curve that you just found)?</a:t>
+            </a:r>
+          </a:p>
+        </p:txBody>
+      </p:sp>
     </p:spTree>
     <p:extLst>
       <p:ext uri="{BB962C8B-B14F-4D97-AF65-F5344CB8AC3E}">
-        <p14:creationId xmlns:p14="http://schemas.microsoft.com/office/powerpoint/2010/main" val="1716557377"/>
-      </p:ext>
-    </p:extLst>
-  </p:cSld>
-  <p:clrMapOvr>
-    <a:masterClrMapping/>
-  </p:clrMapOvr>
-  <p:timing>
-    <p:tnLst>
-      <p:par>
-        <p:cTn id="1" dur="indefinite" restart="never" nodeType="tmRoot"/>
-      </p:par>
-    </p:tnLst>
-  </p:timing>
-</p:sld>
-</file>
-
-<file path=ppt/slides/slide11.xml><?xml version="1.0" encoding="utf-8"?>
-<p:sld xmlns:a="http://schemas.openxmlformats.org/drawingml/2006/main" xmlns:r="http://schemas.openxmlformats.org/officeDocument/2006/relationships" xmlns:p="http://schemas.openxmlformats.org/presentationml/2006/main">
-  <p:cSld>
-    <p:spTree>
-      <p:nvGrpSpPr>
-        <p:cNvPr id="1" name=""/>
-        <p:cNvGrpSpPr/>
-        <p:nvPr/>
-      </p:nvGrpSpPr>
-      <p:grpSpPr>
-        <a:xfrm>
-          <a:off x="0" y="0"/>
-          <a:ext cx="0" cy="0"/>
-          <a:chOff x="0" y="0"/>
-          <a:chExt cx="0" cy="0"/>
-        </a:xfrm>
-      </p:grpSpPr>
-      <p:sp>
-        <p:nvSpPr>
-          <p:cNvPr id="2" name="Title 1"/>
-          <p:cNvSpPr>
-            <a:spLocks noGrp="1"/>
-          </p:cNvSpPr>
-          <p:nvPr>
-            <p:ph type="title"/>
-          </p:nvPr>
-        </p:nvSpPr>
-        <p:spPr/>
-        <p:txBody>
-          <a:bodyPr>
-            <a:normAutofit fontScale="90000"/>
-          </a:bodyPr>
-          <a:lstStyle/>
-          <a:p>
-            <a:r>
-              <a:rPr lang="en-US" dirty="0" err="1" smtClean="0"/>
-              <a:t>Pade</a:t>
-            </a:r>
-            <a:r>
-              <a:rPr lang="en-US" dirty="0" smtClean="0"/>
-              <a:t> Approximation of the Time Delay</a:t>
-            </a:r>
-            <a:endParaRPr lang="en-US" dirty="0"/>
-          </a:p>
-        </p:txBody>
-      </p:sp>
-      <p:pic>
-        <p:nvPicPr>
-          <p:cNvPr id="7" name="Picture 3"/>
-          <p:cNvPicPr>
-            <a:picLocks noGrp="1" noChangeAspect="1" noChangeArrowheads="1"/>
-          </p:cNvPicPr>
-          <p:nvPr>
-            <p:ph idx="1"/>
-          </p:nvPr>
-        </p:nvPicPr>
-        <p:blipFill>
-          <a:blip r:embed="rId2">
-            <a:extLst>
-              <a:ext uri="{28A0092B-C50C-407E-A947-70E740481C1C}">
-                <a14:useLocalDpi xmlns:a14="http://schemas.microsoft.com/office/drawing/2010/main" val="0"/>
-              </a:ext>
-            </a:extLst>
-          </a:blip>
-          <a:srcRect/>
-          <a:stretch>
-            <a:fillRect/>
-          </a:stretch>
-        </p:blipFill>
-        <p:spPr bwMode="auto">
-          <a:xfrm>
-            <a:off x="2938677" y="1600200"/>
-            <a:ext cx="3266646" cy="4525963"/>
-          </a:xfrm>
-          <a:prstGeom prst="rect">
-            <a:avLst/>
-          </a:prstGeom>
-          <a:noFill/>
-          <a:ln>
-            <a:noFill/>
-          </a:ln>
-          <a:effectLst/>
-          <a:extLst>
-            <a:ext uri="{909E8E84-426E-40DD-AFC4-6F175D3DCCD1}">
-              <a14:hiddenFill xmlns:a14="http://schemas.microsoft.com/office/drawing/2010/main">
-                <a:solidFill>
-                  <a:schemeClr val="accent1"/>
-                </a:solidFill>
-              </a14:hiddenFill>
-            </a:ext>
-            <a:ext uri="{91240B29-F687-4F45-9708-019B960494DF}">
-              <a14:hiddenLine xmlns:a14="http://schemas.microsoft.com/office/drawing/2010/main" w="9525">
-                <a:solidFill>
-                  <a:schemeClr val="tx1"/>
-                </a:solidFill>
-                <a:miter lim="800000"/>
-                <a:headEnd/>
-                <a:tailEnd/>
-              </a14:hiddenLine>
-            </a:ext>
-            <a:ext uri="{AF507438-7753-43E0-B8FC-AC1667EBCBE1}">
-              <a14:hiddenEffects xmlns:a14="http://schemas.microsoft.com/office/drawing/2010/main">
-                <a:effectLst>
-                  <a:outerShdw dist="35921" dir="2700000" algn="ctr" rotWithShape="0">
-                    <a:schemeClr val="bg2"/>
-                  </a:outerShdw>
-                </a:effectLst>
-              </a14:hiddenEffects>
-            </a:ext>
-          </a:extLst>
-        </p:spPr>
-      </p:pic>
-    </p:spTree>
-    <p:extLst>
-      <p:ext uri="{BB962C8B-B14F-4D97-AF65-F5344CB8AC3E}">
-        <p14:creationId xmlns:p14="http://schemas.microsoft.com/office/powerpoint/2010/main" val="2588536851"/>
+        <p14:creationId xmlns:p14="http://schemas.microsoft.com/office/powerpoint/2010/main" val="3013434536"/>
       </p:ext>
     </p:extLst>
   </p:cSld>
@@ -3460,7 +3307,7 @@
       </p:grpSpPr>
       <p:sp>
         <p:nvSpPr>
-          <p:cNvPr id="5" name="Title 4"/>
+          <p:cNvPr id="4" name="Title 3"/>
           <p:cNvSpPr>
             <a:spLocks noGrp="1"/>
           </p:cNvSpPr>
@@ -3474,207 +3321,9 @@
           <a:lstStyle/>
           <a:p>
             <a:r>
-              <a:rPr lang="en-US" dirty="0" smtClean="0"/>
-              <a:t>Features</a:t>
-            </a:r>
-            <a:endParaRPr lang="en-US" dirty="0"/>
-          </a:p>
-        </p:txBody>
-      </p:sp>
-      <p:pic>
-        <p:nvPicPr>
-          <p:cNvPr id="4" name="Content Placeholder 3"/>
-          <p:cNvPicPr>
-            <a:picLocks noGrp="1" noChangeAspect="1"/>
-          </p:cNvPicPr>
-          <p:nvPr>
-            <p:ph idx="1"/>
-          </p:nvPr>
-        </p:nvPicPr>
-        <p:blipFill>
-          <a:blip r:embed="rId2">
-            <a:extLst>
-              <a:ext uri="{28A0092B-C50C-407E-A947-70E740481C1C}">
-                <a14:useLocalDpi xmlns:a14="http://schemas.microsoft.com/office/drawing/2010/main" val="0"/>
-              </a:ext>
-            </a:extLst>
-          </a:blip>
-          <a:stretch>
-            <a:fillRect/>
-          </a:stretch>
-        </p:blipFill>
-        <p:spPr>
-          <a:xfrm>
-            <a:off x="3936008" y="273050"/>
-            <a:ext cx="4389834" cy="5853113"/>
-          </a:xfrm>
-          <a:prstGeom prst="rect">
-            <a:avLst/>
-          </a:prstGeom>
-        </p:spPr>
-      </p:pic>
-      <p:sp>
-        <p:nvSpPr>
-          <p:cNvPr id="6" name="Text Placeholder 5"/>
-          <p:cNvSpPr>
-            <a:spLocks noGrp="1"/>
-          </p:cNvSpPr>
-          <p:nvPr>
-            <p:ph type="body" sz="half" idx="2"/>
-          </p:nvPr>
-        </p:nvSpPr>
-        <p:spPr/>
-        <p:txBody>
-          <a:bodyPr/>
-          <a:lstStyle/>
-          <a:p>
-            <a:pPr marL="285750" indent="-285750">
-              <a:buFontTx/>
-              <a:buChar char="-"/>
-            </a:pPr>
-            <a:r>
-              <a:rPr lang="en-US" dirty="0" smtClean="0"/>
-              <a:t>Very compact in size</a:t>
-            </a:r>
-          </a:p>
-          <a:p>
-            <a:pPr marL="285750" indent="-285750">
-              <a:buFontTx/>
-              <a:buChar char="-"/>
-            </a:pPr>
-            <a:r>
-              <a:rPr lang="en-US" dirty="0" smtClean="0"/>
-              <a:t>Inexpensive</a:t>
-            </a:r>
-            <a:endParaRPr lang="en-US" dirty="0" smtClean="0"/>
-          </a:p>
-          <a:p>
-            <a:pPr marL="285750" indent="-285750">
-              <a:buFontTx/>
-              <a:buChar char="-"/>
-            </a:pPr>
-            <a:r>
-              <a:rPr lang="en-US" dirty="0" smtClean="0"/>
-              <a:t>Two heaters </a:t>
-            </a:r>
-            <a:r>
-              <a:rPr lang="en-US" dirty="0" smtClean="0"/>
-              <a:t>and two temperature sensors</a:t>
-            </a:r>
-          </a:p>
-          <a:p>
-            <a:pPr marL="285750" indent="-285750">
-              <a:buFontTx/>
-              <a:buChar char="-"/>
-            </a:pPr>
-            <a:r>
               <a:rPr lang="en-US" dirty="0"/>
-              <a:t>Excellent linearity at steady state condition when the temperature is below 120 </a:t>
-            </a:r>
-            <a:r>
-              <a:rPr lang="en-US" dirty="0" err="1"/>
-              <a:t>degress</a:t>
-            </a:r>
-            <a:r>
-              <a:rPr lang="en-US" dirty="0"/>
-              <a:t> of </a:t>
-            </a:r>
-            <a:r>
-              <a:rPr lang="en-US" dirty="0" err="1"/>
-              <a:t>Celcius</a:t>
-            </a:r>
-            <a:r>
-              <a:rPr lang="en-US" dirty="0"/>
-              <a:t>.</a:t>
-            </a:r>
-            <a:r>
-              <a:rPr lang="en-US" dirty="0"/>
-              <a:t> </a:t>
-            </a:r>
-            <a:endParaRPr lang="en-US" dirty="0" smtClean="0"/>
-          </a:p>
-          <a:p>
-            <a:pPr marL="285750" indent="-285750">
-              <a:buFontTx/>
-              <a:buChar char="-"/>
-            </a:pPr>
-            <a:r>
-              <a:rPr lang="en-US" dirty="0"/>
-              <a:t>Each heater can be heated to about 140 degrees of </a:t>
-            </a:r>
-            <a:r>
-              <a:rPr lang="en-US" dirty="0" err="1"/>
-              <a:t>Celcius</a:t>
-            </a:r>
-            <a:r>
-              <a:rPr lang="en-US" dirty="0"/>
-              <a:t>.</a:t>
-            </a:r>
-            <a:r>
-              <a:rPr lang="en-US" dirty="0"/>
-              <a:t> </a:t>
-            </a:r>
-            <a:endParaRPr lang="en-US" dirty="0" smtClean="0"/>
-          </a:p>
-        </p:txBody>
-      </p:sp>
-    </p:spTree>
-    <p:extLst>
-      <p:ext uri="{BB962C8B-B14F-4D97-AF65-F5344CB8AC3E}">
-        <p14:creationId xmlns:p14="http://schemas.microsoft.com/office/powerpoint/2010/main" val="2577293424"/>
-      </p:ext>
-    </p:extLst>
-  </p:cSld>
-  <p:clrMapOvr>
-    <a:masterClrMapping/>
-  </p:clrMapOvr>
-  <p:timing>
-    <p:tnLst>
-      <p:par>
-        <p:cTn id="1" dur="indefinite" restart="never" nodeType="tmRoot"/>
-      </p:par>
-    </p:tnLst>
-  </p:timing>
-</p:sld>
-</file>
-
-<file path=ppt/slides/slide3.xml><?xml version="1.0" encoding="utf-8"?>
-<p:sld xmlns:a="http://schemas.openxmlformats.org/drawingml/2006/main" xmlns:r="http://schemas.openxmlformats.org/officeDocument/2006/relationships" xmlns:p="http://schemas.openxmlformats.org/presentationml/2006/main">
-  <p:cSld>
-    <p:spTree>
-      <p:nvGrpSpPr>
-        <p:cNvPr id="1" name=""/>
-        <p:cNvGrpSpPr/>
-        <p:nvPr/>
-      </p:nvGrpSpPr>
-      <p:grpSpPr>
-        <a:xfrm>
-          <a:off x="0" y="0"/>
-          <a:ext cx="0" cy="0"/>
-          <a:chOff x="0" y="0"/>
-          <a:chExt cx="0" cy="0"/>
-        </a:xfrm>
-      </p:grpSpPr>
-      <p:sp>
-        <p:nvSpPr>
-          <p:cNvPr id="4" name="Title 3"/>
-          <p:cNvSpPr>
-            <a:spLocks noGrp="1"/>
-          </p:cNvSpPr>
-          <p:nvPr>
-            <p:ph type="title"/>
-          </p:nvPr>
-        </p:nvSpPr>
-        <p:spPr/>
-        <p:txBody>
-          <a:bodyPr/>
-          <a:lstStyle/>
-          <a:p>
-            <a:r>
-              <a:rPr lang="en-US" dirty="0" smtClean="0"/>
               <a:t>Step response Experiment</a:t>
             </a:r>
-            <a:endParaRPr lang="en-US" dirty="0"/>
           </a:p>
         </p:txBody>
       </p:sp>
@@ -3718,13 +3367,97 @@
   <p:clrMapOvr>
     <a:masterClrMapping/>
   </p:clrMapOvr>
-  <p:timing>
-    <p:tnLst>
-      <p:par>
-        <p:cTn id="1" dur="indefinite" restart="never" nodeType="tmRoot"/>
-      </p:par>
-    </p:tnLst>
-  </p:timing>
+</p:sld>
+</file>
+
+<file path=ppt/slides/slide3.xml><?xml version="1.0" encoding="utf-8"?>
+<p:sld xmlns:a="http://schemas.openxmlformats.org/drawingml/2006/main" xmlns:r="http://schemas.openxmlformats.org/officeDocument/2006/relationships" xmlns:p="http://schemas.openxmlformats.org/presentationml/2006/main">
+  <p:cSld>
+    <p:spTree>
+      <p:nvGrpSpPr>
+        <p:cNvPr id="1" name=""/>
+        <p:cNvGrpSpPr/>
+        <p:nvPr/>
+      </p:nvGrpSpPr>
+      <p:grpSpPr>
+        <a:xfrm>
+          <a:off x="0" y="0"/>
+          <a:ext cx="0" cy="0"/>
+          <a:chOff x="0" y="0"/>
+          <a:chExt cx="0" cy="0"/>
+        </a:xfrm>
+      </p:grpSpPr>
+      <p:sp>
+        <p:nvSpPr>
+          <p:cNvPr id="4" name="Title 3"/>
+          <p:cNvSpPr>
+            <a:spLocks noGrp="1"/>
+          </p:cNvSpPr>
+          <p:nvPr>
+            <p:ph type="title"/>
+          </p:nvPr>
+        </p:nvSpPr>
+        <p:spPr/>
+        <p:txBody>
+          <a:bodyPr/>
+          <a:lstStyle/>
+          <a:p>
+            <a:endParaRPr lang="en-US"/>
+          </a:p>
+        </p:txBody>
+      </p:sp>
+      <p:sp>
+        <p:nvSpPr>
+          <p:cNvPr id="5" name="Content Placeholder 4"/>
+          <p:cNvSpPr>
+            <a:spLocks noGrp="1"/>
+          </p:cNvSpPr>
+          <p:nvPr>
+            <p:ph idx="1"/>
+          </p:nvPr>
+        </p:nvSpPr>
+        <p:spPr/>
+        <p:txBody>
+          <a:bodyPr/>
+          <a:lstStyle/>
+          <a:p>
+            <a:r>
+              <a:rPr lang="en-US" dirty="0"/>
+              <a:t>Apply an input of 50%.</a:t>
+            </a:r>
+          </a:p>
+          <a:p>
+            <a:r>
+              <a:rPr lang="en-US" dirty="0"/>
+              <a:t>Run the Simulink, record the time, the input and the output.</a:t>
+            </a:r>
+          </a:p>
+          <a:p>
+            <a:r>
+              <a:rPr lang="en-US" dirty="0"/>
+              <a:t>Run for at least for 1</a:t>
+            </a:r>
+            <a:r>
+              <a:rPr lang="id-ID" dirty="0"/>
+              <a:t>5</a:t>
+            </a:r>
+            <a:r>
+              <a:rPr lang="en-US" dirty="0"/>
+              <a:t>00 seconds.</a:t>
+            </a:r>
+          </a:p>
+        </p:txBody>
+      </p:sp>
+    </p:spTree>
+    <p:extLst>
+      <p:ext uri="{BB962C8B-B14F-4D97-AF65-F5344CB8AC3E}">
+        <p14:creationId xmlns:p14="http://schemas.microsoft.com/office/powerpoint/2010/main" val="897510123"/>
+      </p:ext>
+    </p:extLst>
+  </p:cSld>
+  <p:clrMapOvr>
+    <a:masterClrMapping/>
+  </p:clrMapOvr>
 </p:sld>
 </file>
 
@@ -3747,7 +3480,7 @@
       </p:grpSpPr>
       <p:sp>
         <p:nvSpPr>
-          <p:cNvPr id="4" name="Title 3"/>
+          <p:cNvPr id="2" name="Title 1"/>
           <p:cNvSpPr>
             <a:spLocks noGrp="1"/>
           </p:cNvSpPr>
@@ -3760,101 +3493,10 @@
           <a:bodyPr/>
           <a:lstStyle/>
           <a:p>
-            <a:endParaRPr lang="en-US"/>
-          </a:p>
-        </p:txBody>
-      </p:sp>
-      <p:sp>
-        <p:nvSpPr>
-          <p:cNvPr id="5" name="Content Placeholder 4"/>
-          <p:cNvSpPr>
-            <a:spLocks noGrp="1"/>
-          </p:cNvSpPr>
-          <p:nvPr>
-            <p:ph idx="1"/>
-          </p:nvPr>
-        </p:nvSpPr>
-        <p:spPr/>
-        <p:txBody>
-          <a:bodyPr/>
-          <a:lstStyle/>
-          <a:p>
-            <a:r>
-              <a:rPr lang="en-US" dirty="0" smtClean="0"/>
-              <a:t>Apply an input of 50%.</a:t>
-            </a:r>
-          </a:p>
-          <a:p>
-            <a:r>
-              <a:rPr lang="en-US" dirty="0" smtClean="0"/>
-              <a:t>Run the Simulink, record the time, the input and the output.</a:t>
-            </a:r>
-          </a:p>
-          <a:p>
-            <a:r>
-              <a:rPr lang="en-US" dirty="0" smtClean="0"/>
-              <a:t>Run for at least for 1300 seconds.</a:t>
-            </a:r>
-          </a:p>
-          <a:p>
-            <a:r>
-              <a:rPr lang="en-US" dirty="0" smtClean="0"/>
-              <a:t>Here, it is fine to reduce the sampling rate to 100 Hz.</a:t>
-            </a:r>
-            <a:endParaRPr lang="en-US" dirty="0"/>
-          </a:p>
-        </p:txBody>
-      </p:sp>
-    </p:spTree>
-    <p:extLst>
-      <p:ext uri="{BB962C8B-B14F-4D97-AF65-F5344CB8AC3E}">
-        <p14:creationId xmlns:p14="http://schemas.microsoft.com/office/powerpoint/2010/main" val="897510123"/>
-      </p:ext>
-    </p:extLst>
-  </p:cSld>
-  <p:clrMapOvr>
-    <a:masterClrMapping/>
-  </p:clrMapOvr>
-</p:sld>
-</file>
-
-<file path=ppt/slides/slide5.xml><?xml version="1.0" encoding="utf-8"?>
-<p:sld xmlns:a="http://schemas.openxmlformats.org/drawingml/2006/main" xmlns:r="http://schemas.openxmlformats.org/officeDocument/2006/relationships" xmlns:p="http://schemas.openxmlformats.org/presentationml/2006/main">
-  <p:cSld>
-    <p:spTree>
-      <p:nvGrpSpPr>
-        <p:cNvPr id="1" name=""/>
-        <p:cNvGrpSpPr/>
-        <p:nvPr/>
-      </p:nvGrpSpPr>
-      <p:grpSpPr>
-        <a:xfrm>
-          <a:off x="0" y="0"/>
-          <a:ext cx="0" cy="0"/>
-          <a:chOff x="0" y="0"/>
-          <a:chExt cx="0" cy="0"/>
-        </a:xfrm>
-      </p:grpSpPr>
-      <p:sp>
-        <p:nvSpPr>
-          <p:cNvPr id="2" name="Title 1"/>
-          <p:cNvSpPr>
-            <a:spLocks noGrp="1"/>
-          </p:cNvSpPr>
-          <p:nvPr>
-            <p:ph type="title"/>
-          </p:nvPr>
-        </p:nvSpPr>
-        <p:spPr/>
-        <p:txBody>
-          <a:bodyPr/>
-          <a:lstStyle/>
-          <a:p>
-            <a:r>
-              <a:rPr lang="en-US" dirty="0" smtClean="0"/>
+            <a:r>
+              <a:rPr lang="en-US" dirty="0"/>
               <a:t>50% of Input PWM</a:t>
             </a:r>
-            <a:endParaRPr lang="en-US" dirty="0"/>
           </a:p>
         </p:txBody>
       </p:sp>
@@ -3934,17 +3576,10 @@
   <p:clrMapOvr>
     <a:masterClrMapping/>
   </p:clrMapOvr>
-  <p:timing>
-    <p:tnLst>
-      <p:par>
-        <p:cTn id="1" dur="indefinite" restart="never" nodeType="tmRoot"/>
-      </p:par>
-    </p:tnLst>
-  </p:timing>
 </p:sld>
 </file>
 
-<file path=ppt/slides/slide6.xml><?xml version="1.0" encoding="utf-8"?>
+<file path=ppt/slides/slide5.xml><?xml version="1.0" encoding="utf-8"?>
 <p:sld xmlns:a="http://schemas.openxmlformats.org/drawingml/2006/main" xmlns:r="http://schemas.openxmlformats.org/officeDocument/2006/relationships" xmlns:p="http://schemas.openxmlformats.org/presentationml/2006/main">
   <p:cSld>
     <p:spTree>
@@ -3979,10 +3614,9 @@
           <a:lstStyle/>
           <a:p>
             <a:r>
-              <a:rPr lang="en-US" dirty="0" smtClean="0"/>
+              <a:rPr lang="en-US" dirty="0"/>
               <a:t>Temperature offset has been removed</a:t>
             </a:r>
-            <a:endParaRPr lang="en-US" dirty="0"/>
           </a:p>
         </p:txBody>
       </p:sp>
@@ -4087,7 +3721,7 @@
                         <m:sSubPr>
                           <m:ctrlPr>
                             <a:rPr lang="en-US" b="0" i="1" smtClean="0">
-                              <a:latin typeface="Cambria Math"/>
+                              <a:latin typeface="Cambria Math" panose="02040503050406030204" pitchFamily="18" charset="0"/>
                             </a:rPr>
                           </m:ctrlPr>
                         </m:sSubPr>
@@ -4268,7 +3902,7 @@
 </p:sld>
 </file>
 
-<file path=ppt/slides/slide7.xml><?xml version="1.0" encoding="utf-8"?>
+<file path=ppt/slides/slide6.xml><?xml version="1.0" encoding="utf-8"?>
 <p:sld xmlns:a="http://schemas.openxmlformats.org/drawingml/2006/main" xmlns:r="http://schemas.openxmlformats.org/officeDocument/2006/relationships" xmlns:p="http://schemas.openxmlformats.org/presentationml/2006/main">
   <p:cSld>
     <p:spTree>
@@ -4298,6 +3932,15 @@
         <p:blipFill>
           <a:blip r:embed="rId2">
             <a:extLst>
+              <a:ext uri="{BEBA8EAE-BF5A-486C-A8C5-ECC9F3942E4B}">
+                <a14:imgProps xmlns:a14="http://schemas.microsoft.com/office/drawing/2010/main">
+                  <a14:imgLayer r:embed="rId3">
+                    <a14:imgEffect>
+                      <a14:brightnessContrast contrast="40000"/>
+                    </a14:imgEffect>
+                  </a14:imgLayer>
+                </a14:imgProps>
+              </a:ext>
               <a:ext uri="{28A0092B-C50C-407E-A947-70E740481C1C}">
                 <a14:useLocalDpi xmlns:a14="http://schemas.microsoft.com/office/drawing/2010/main" val="0"/>
               </a:ext>
@@ -4351,8 +3994,8 @@
           </a:extLst>
         </p:spPr>
       </p:pic>
-      <mc:AlternateContent xmlns:mc="http://schemas.openxmlformats.org/markup-compatibility/2006">
-        <mc:Choice xmlns:a14="http://schemas.microsoft.com/office/drawing/2010/main" Requires="a14">
+      <mc:AlternateContent xmlns:mc="http://schemas.openxmlformats.org/markup-compatibility/2006" xmlns:a14="http://schemas.microsoft.com/office/drawing/2010/main">
+        <mc:Choice Requires="a14">
           <p:sp>
             <p:nvSpPr>
               <p:cNvPr id="2" name="Title 1"/>
@@ -4371,7 +4014,7 @@
               <a:lstStyle/>
               <a:p>
                 <a:r>
-                  <a:rPr lang="en-US" dirty="0" smtClean="0"/>
+                  <a:rPr lang="en-US" dirty="0"/>
                   <a:t>Zoomed-in around </a:t>
                 </a:r>
                 <a14:m>
@@ -4395,7 +4038,7 @@
             </p:txBody>
           </p:sp>
         </mc:Choice>
-        <mc:Fallback>
+        <mc:Fallback xmlns="">
           <p:sp>
             <p:nvSpPr>
               <p:cNvPr id="2" name="Title 1"/>
@@ -4408,7 +4051,7 @@
             </p:nvSpPr>
             <p:spPr>
               <a:blipFill rotWithShape="1">
-                <a:blip r:embed="rId3"/>
+                <a:blip r:embed="rId4"/>
                 <a:stretch>
                   <a:fillRect b="-8511"/>
                 </a:stretch>
@@ -4465,8 +4108,8 @@
           </a:fontRef>
         </p:style>
       </p:cxnSp>
-      <mc:AlternateContent xmlns:mc="http://schemas.openxmlformats.org/markup-compatibility/2006">
-        <mc:Choice xmlns:a14="http://schemas.microsoft.com/office/drawing/2010/main" Requires="a14">
+      <mc:AlternateContent xmlns:mc="http://schemas.openxmlformats.org/markup-compatibility/2006" xmlns:a14="http://schemas.microsoft.com/office/drawing/2010/main">
+        <mc:Choice Requires="a14">
           <p:sp>
             <p:nvSpPr>
               <p:cNvPr id="6" name="TextBox 5"/>
@@ -4490,7 +4133,7 @@
               <a:lstStyle/>
               <a:p>
                 <a:r>
-                  <a:rPr lang="en-US" dirty="0" smtClean="0"/>
+                  <a:rPr lang="en-US" dirty="0"/>
                   <a:t>Input starts at </a:t>
                 </a:r>
                 <a14:m>
@@ -4514,7 +4157,7 @@
             </p:txBody>
           </p:sp>
         </mc:Choice>
-        <mc:Fallback>
+        <mc:Fallback xmlns="">
           <p:sp>
             <p:nvSpPr>
               <p:cNvPr id="6" name="TextBox 5"/>
@@ -4532,7 +4175,7 @@
                 <a:avLst/>
               </a:prstGeom>
               <a:blipFill rotWithShape="1">
-                <a:blip r:embed="rId4"/>
+                <a:blip r:embed="rId5"/>
                 <a:stretch>
                   <a:fillRect l="-2353" t="-8197" b="-24590"/>
                 </a:stretch>
@@ -4612,10 +4255,9 @@
           <a:lstStyle/>
           <a:p>
             <a:r>
-              <a:rPr lang="en-US" dirty="0" smtClean="0"/>
+              <a:rPr lang="en-US" dirty="0"/>
               <a:t>Time delay</a:t>
             </a:r>
-            <a:endParaRPr lang="en-US" dirty="0"/>
           </a:p>
         </p:txBody>
       </p:sp>
@@ -4690,7 +4332,7 @@
                 <a:avLst/>
               </a:prstGeom>
               <a:blipFill rotWithShape="1">
-                <a:blip r:embed="rId5"/>
+                <a:blip r:embed="rId6"/>
                 <a:stretch>
                   <a:fillRect/>
                 </a:stretch>
@@ -4746,7 +4388,7 @@
                         <m:sSubPr>
                           <m:ctrlPr>
                             <a:rPr lang="en-US" b="0" i="1" smtClean="0">
-                              <a:latin typeface="Cambria Math"/>
+                              <a:latin typeface="Cambria Math" panose="02040503050406030204" pitchFamily="18" charset="0"/>
                             </a:rPr>
                           </m:ctrlPr>
                         </m:sSubPr>
@@ -4793,7 +4435,7 @@
                 <a:avLst/>
               </a:prstGeom>
               <a:blipFill rotWithShape="1">
-                <a:blip r:embed="rId6"/>
+                <a:blip r:embed="rId7"/>
                 <a:stretch>
                   <a:fillRect b="-4918"/>
                 </a:stretch>
@@ -4824,17 +4466,10 @@
   <p:clrMapOvr>
     <a:masterClrMapping/>
   </p:clrMapOvr>
-  <p:timing>
-    <p:tnLst>
-      <p:par>
-        <p:cTn id="1" dur="indefinite" restart="never" nodeType="tmRoot"/>
-      </p:par>
-    </p:tnLst>
-  </p:timing>
 </p:sld>
 </file>
 
-<file path=ppt/slides/slide8.xml><?xml version="1.0" encoding="utf-8"?>
+<file path=ppt/slides/slide7.xml><?xml version="1.0" encoding="utf-8"?>
 <p:sld xmlns:a="http://schemas.openxmlformats.org/drawingml/2006/main" xmlns:r="http://schemas.openxmlformats.org/officeDocument/2006/relationships" xmlns:p="http://schemas.openxmlformats.org/presentationml/2006/main">
   <p:cSld>
     <p:spTree>
@@ -4867,23 +4502,14 @@
           <a:lstStyle/>
           <a:p>
             <a:r>
-              <a:rPr lang="en-US" dirty="0" smtClean="0"/>
-              <a:t>The TDTC </a:t>
-            </a:r>
-            <a:r>
               <a:rPr lang="en-US" dirty="0"/>
-              <a:t>m</a:t>
-            </a:r>
-            <a:r>
-              <a:rPr lang="en-US" dirty="0" smtClean="0"/>
-              <a:t>odel</a:t>
-            </a:r>
-            <a:endParaRPr lang="en-US" dirty="0"/>
-          </a:p>
-        </p:txBody>
-      </p:sp>
-      <mc:AlternateContent xmlns:mc="http://schemas.openxmlformats.org/markup-compatibility/2006" xmlns:a14="http://schemas.microsoft.com/office/drawing/2010/main">
-        <mc:Choice Requires="a14">
+              <a:t>The TDTC model</a:t>
+            </a:r>
+          </a:p>
+        </p:txBody>
+      </p:sp>
+      <mc:AlternateContent xmlns:mc="http://schemas.openxmlformats.org/markup-compatibility/2006">
+        <mc:Choice xmlns:a14="http://schemas.microsoft.com/office/drawing/2010/main" Requires="a14">
           <p:sp>
             <p:nvSpPr>
               <p:cNvPr id="3" name="Content Placeholder 2"/>
@@ -4918,7 +4544,7 @@
                         <m:dPr>
                           <m:ctrlPr>
                             <a:rPr lang="en-US" b="0" i="1" smtClean="0">
-                              <a:latin typeface="Cambria Math"/>
+                              <a:latin typeface="Cambria Math" panose="02040503050406030204" pitchFamily="18" charset="0"/>
                             </a:rPr>
                           </m:ctrlPr>
                         </m:dPr>
@@ -4941,7 +4567,7 @@
                         <m:sSubPr>
                           <m:ctrlPr>
                             <a:rPr lang="en-US" b="0" i="1" smtClean="0">
-                              <a:latin typeface="Cambria Math"/>
+                              <a:latin typeface="Cambria Math" panose="02040503050406030204" pitchFamily="18" charset="0"/>
                             </a:rPr>
                           </m:ctrlPr>
                         </m:sSubPr>
@@ -4956,7 +4582,7 @@
                         <m:sub>
                           <m:r>
                             <a:rPr lang="en-US" b="0" i="1" smtClean="0">
-                              <a:latin typeface="Cambria Math"/>
+                              <a:latin typeface="Cambria Math" panose="02040503050406030204" pitchFamily="18" charset="0"/>
                             </a:rPr>
                             <m:t>𝑠𝑠</m:t>
                           </m:r>
@@ -4966,7 +4592,7 @@
                         <m:fPr>
                           <m:ctrlPr>
                             <a:rPr lang="en-US" b="0" i="1" smtClean="0">
-                              <a:latin typeface="Cambria Math"/>
+                              <a:latin typeface="Cambria Math" panose="02040503050406030204" pitchFamily="18" charset="0"/>
                             </a:rPr>
                           </m:ctrlPr>
                         </m:fPr>
@@ -4975,7 +4601,7 @@
                             <m:sSupPr>
                               <m:ctrlPr>
                                 <a:rPr lang="en-US" b="0" i="1" smtClean="0">
-                                  <a:latin typeface="Cambria Math"/>
+                                  <a:latin typeface="Cambria Math" panose="02040503050406030204" pitchFamily="18" charset="0"/>
                                 </a:rPr>
                               </m:ctrlPr>
                             </m:sSupPr>
@@ -5038,18 +4664,18 @@
                     </m:oMath>
                   </m:oMathPara>
                 </a14:m>
-                <a:endParaRPr lang="en-US" b="0" dirty="0" smtClean="0"/>
+                <a:endParaRPr lang="en-US" b="0" dirty="0"/>
               </a:p>
               <a:p>
                 <a:pPr marL="0" indent="0">
                   <a:buNone/>
                 </a:pPr>
-                <a:endParaRPr lang="en-US" dirty="0" smtClean="0"/>
+                <a:endParaRPr lang="en-US" dirty="0"/>
               </a:p>
             </p:txBody>
           </p:sp>
         </mc:Choice>
-        <mc:Fallback xmlns="">
+        <mc:Fallback>
           <p:sp>
             <p:nvSpPr>
               <p:cNvPr id="3" name="Content Placeholder 2"/>
@@ -5061,7 +4687,7 @@
               </p:nvPr>
             </p:nvSpPr>
             <p:spPr>
-              <a:blipFill rotWithShape="1">
+              <a:blipFill>
                 <a:blip r:embed="rId2"/>
                 <a:stretch>
                   <a:fillRect/>
@@ -5160,7 +4786,7 @@
 </p:sld>
 </file>
 
-<file path=ppt/slides/slide9.xml><?xml version="1.0" encoding="utf-8"?>
+<file path=ppt/slides/slide8.xml><?xml version="1.0" encoding="utf-8"?>
 <p:sld xmlns:a="http://schemas.openxmlformats.org/drawingml/2006/main" xmlns:r="http://schemas.openxmlformats.org/officeDocument/2006/relationships" xmlns:p="http://schemas.openxmlformats.org/presentationml/2006/main">
   <p:cSld>
     <p:spTree>
@@ -5193,15 +4819,14 @@
           <a:lstStyle/>
           <a:p>
             <a:r>
-              <a:rPr lang="en-US" dirty="0" smtClean="0"/>
+              <a:rPr lang="en-US" dirty="0"/>
               <a:t>Find all the parameters</a:t>
             </a:r>
-            <a:endParaRPr lang="en-US" dirty="0"/>
-          </a:p>
-        </p:txBody>
-      </p:sp>
-      <mc:AlternateContent xmlns:mc="http://schemas.openxmlformats.org/markup-compatibility/2006" xmlns:a14="http://schemas.microsoft.com/office/drawing/2010/main">
-        <mc:Choice Requires="a14">
+          </a:p>
+        </p:txBody>
+      </p:sp>
+      <mc:AlternateContent xmlns:mc="http://schemas.openxmlformats.org/markup-compatibility/2006">
+        <mc:Choice xmlns:a14="http://schemas.microsoft.com/office/drawing/2010/main" Requires="a14">
           <p:sp>
             <p:nvSpPr>
               <p:cNvPr id="3" name="Content Placeholder 2"/>
@@ -5237,7 +4862,7 @@
                         <m:sSubPr>
                           <m:ctrlPr>
                             <a:rPr lang="en-US" i="1" smtClean="0">
-                              <a:latin typeface="Cambria Math"/>
+                              <a:latin typeface="Cambria Math" panose="02040503050406030204" pitchFamily="18" charset="0"/>
                             </a:rPr>
                           </m:ctrlPr>
                         </m:sSubPr>
@@ -5302,7 +4927,7 @@
                     </m:oMath>
                   </m:oMathPara>
                 </a14:m>
-                <a:endParaRPr lang="en-US" dirty="0" smtClean="0"/>
+                <a:endParaRPr lang="en-US" dirty="0"/>
               </a:p>
               <a:p>
                 <a:pPr marL="0" indent="0">
@@ -5318,7 +4943,7 @@
                         <m:sSubPr>
                           <m:ctrlPr>
                             <a:rPr lang="en-US" i="1">
-                              <a:latin typeface="Cambria Math"/>
+                              <a:latin typeface="Cambria Math" panose="02040503050406030204" pitchFamily="18" charset="0"/>
                             </a:rPr>
                           </m:ctrlPr>
                         </m:sSubPr>
@@ -5373,7 +4998,7 @@
                     </m:oMath>
                   </m:oMathPara>
                 </a14:m>
-                <a:endParaRPr lang="en-US" b="0" dirty="0" smtClean="0"/>
+                <a:endParaRPr lang="en-US" b="0" dirty="0"/>
               </a:p>
               <a:p>
                 <a:pPr marL="0" indent="0">
@@ -5389,7 +5014,7 @@
                         <m:sSubPr>
                           <m:ctrlPr>
                             <a:rPr lang="en-US" b="0" i="1" smtClean="0">
-                              <a:latin typeface="Cambria Math"/>
+                              <a:latin typeface="Cambria Math" panose="02040503050406030204" pitchFamily="18" charset="0"/>
                             </a:rPr>
                           </m:ctrlPr>
                         </m:sSubPr>
@@ -5416,10 +5041,23 @@
                         </a:rPr>
                         <m:t>=243.6</m:t>
                       </m:r>
+                      <m:r>
+                        <a:rPr lang="id-ID" b="0" i="1" smtClean="0">
+                          <a:latin typeface="Cambria Math" panose="02040503050406030204" pitchFamily="18" charset="0"/>
+                        </a:rPr>
+                        <m:t>=</m:t>
+                      </m:r>
+                      <m:r>
+                        <a:rPr lang="id-ID" b="0" i="1" smtClean="0">
+                          <a:latin typeface="Cambria Math" panose="02040503050406030204" pitchFamily="18" charset="0"/>
+                          <a:ea typeface="Cambria Math" panose="02040503050406030204" pitchFamily="18" charset="0"/>
+                        </a:rPr>
+                        <m:t>𝜏</m:t>
+                      </m:r>
                     </m:oMath>
                   </m:oMathPara>
                 </a14:m>
-                <a:endParaRPr lang="en-US" dirty="0" smtClean="0"/>
+                <a:endParaRPr lang="en-US" dirty="0"/>
               </a:p>
               <a:p>
                 <a:pPr marL="0" indent="0">
@@ -5435,7 +5073,7 @@
                         <m:sSubPr>
                           <m:ctrlPr>
                             <a:rPr lang="en-US" b="0" i="1" smtClean="0">
-                              <a:latin typeface="Cambria Math"/>
+                              <a:latin typeface="Cambria Math" panose="02040503050406030204" pitchFamily="18" charset="0"/>
                             </a:rPr>
                           </m:ctrlPr>
                         </m:sSubPr>
@@ -5450,7 +5088,7 @@
                         <m:sub>
                           <m:r>
                             <a:rPr lang="en-US" b="0" i="1" smtClean="0">
-                              <a:latin typeface="Cambria Math"/>
+                              <a:latin typeface="Cambria Math" panose="02040503050406030204" pitchFamily="18" charset="0"/>
                             </a:rPr>
                             <m:t>𝑠𝑠</m:t>
                           </m:r>
@@ -5466,7 +5104,7 @@
                         <m:fPr>
                           <m:ctrlPr>
                             <a:rPr lang="en-US" b="0" i="1" smtClean="0">
-                              <a:latin typeface="Cambria Math"/>
+                              <a:latin typeface="Cambria Math" panose="02040503050406030204" pitchFamily="18" charset="0"/>
                             </a:rPr>
                           </m:ctrlPr>
                         </m:fPr>
@@ -5502,7 +5140,7 @@
                 <a:pPr marL="0" indent="0">
                   <a:buNone/>
                 </a:pPr>
-                <a:endParaRPr lang="en-US" dirty="0" smtClean="0"/>
+                <a:endParaRPr lang="en-US" dirty="0"/>
               </a:p>
               <a:p>
                 <a:pPr marL="0" indent="0">
@@ -5513,7 +5151,7 @@
             </p:txBody>
           </p:sp>
         </mc:Choice>
-        <mc:Fallback xmlns="">
+        <mc:Fallback>
           <p:sp>
             <p:nvSpPr>
               <p:cNvPr id="3" name="Content Placeholder 2"/>
@@ -5529,7 +5167,7 @@
                 <a:off x="683568" y="2204864"/>
                 <a:ext cx="4320480" cy="3057203"/>
               </a:xfrm>
-              <a:blipFill rotWithShape="1">
+              <a:blipFill>
                 <a:blip r:embed="rId2"/>
                 <a:stretch>
                   <a:fillRect/>
@@ -5562,6 +5200,15 @@
         <p:blipFill>
           <a:blip r:embed="rId3">
             <a:extLst>
+              <a:ext uri="{BEBA8EAE-BF5A-486C-A8C5-ECC9F3942E4B}">
+                <a14:imgProps xmlns:a14="http://schemas.microsoft.com/office/drawing/2010/main">
+                  <a14:imgLayer r:embed="rId4">
+                    <a14:imgEffect>
+                      <a14:brightnessContrast bright="20000" contrast="40000"/>
+                    </a14:imgEffect>
+                  </a14:imgLayer>
+                </a14:imgProps>
+              </a:ext>
               <a:ext uri="{28A0092B-C50C-407E-A947-70E740481C1C}">
                 <a14:useLocalDpi xmlns:a14="http://schemas.microsoft.com/office/drawing/2010/main" val="0"/>
               </a:ext>
@@ -5651,8 +5298,8 @@
           </a:fontRef>
         </p:style>
       </p:cxnSp>
-      <mc:AlternateContent xmlns:mc="http://schemas.openxmlformats.org/markup-compatibility/2006">
-        <mc:Choice xmlns:a14="http://schemas.microsoft.com/office/drawing/2010/main" Requires="a14">
+      <mc:AlternateContent xmlns:mc="http://schemas.openxmlformats.org/markup-compatibility/2006" xmlns:a14="http://schemas.microsoft.com/office/drawing/2010/main">
+        <mc:Choice Requires="a14">
           <p:sp>
             <p:nvSpPr>
               <p:cNvPr id="7" name="TextBox 6"/>
@@ -5675,6 +5322,7 @@
               </a:bodyPr>
               <a:lstStyle/>
               <a:p>
+                <a:pPr/>
                 <a14:m>
                   <m:oMathPara xmlns:m="http://schemas.openxmlformats.org/officeDocument/2006/math">
                     <m:oMathParaPr>
@@ -5696,7 +5344,7 @@
             </p:txBody>
           </p:sp>
         </mc:Choice>
-        <mc:Fallback>
+        <mc:Fallback xmlns="">
           <p:sp>
             <p:nvSpPr>
               <p:cNvPr id="7" name="TextBox 6"/>
@@ -5714,7 +5362,7 @@
                 <a:avLst/>
               </a:prstGeom>
               <a:blipFill rotWithShape="1">
-                <a:blip r:embed="rId4"/>
+                <a:blip r:embed="rId5"/>
                 <a:stretch>
                   <a:fillRect/>
                 </a:stretch>
@@ -5773,6 +5421,131 @@
     <p:extLst>
       <p:ext uri="{BB962C8B-B14F-4D97-AF65-F5344CB8AC3E}">
         <p14:creationId xmlns:p14="http://schemas.microsoft.com/office/powerpoint/2010/main" val="712264086"/>
+      </p:ext>
+    </p:extLst>
+  </p:cSld>
+  <p:clrMapOvr>
+    <a:masterClrMapping/>
+  </p:clrMapOvr>
+</p:sld>
+</file>
+
+<file path=ppt/slides/slide9.xml><?xml version="1.0" encoding="utf-8"?>
+<p:sld xmlns:a="http://schemas.openxmlformats.org/drawingml/2006/main" xmlns:r="http://schemas.openxmlformats.org/officeDocument/2006/relationships" xmlns:p="http://schemas.openxmlformats.org/presentationml/2006/main">
+  <p:cSld>
+    <p:spTree>
+      <p:nvGrpSpPr>
+        <p:cNvPr id="1" name=""/>
+        <p:cNvGrpSpPr/>
+        <p:nvPr/>
+      </p:nvGrpSpPr>
+      <p:grpSpPr>
+        <a:xfrm>
+          <a:off x="0" y="0"/>
+          <a:ext cx="0" cy="0"/>
+          <a:chOff x="0" y="0"/>
+          <a:chExt cx="0" cy="0"/>
+        </a:xfrm>
+      </p:grpSpPr>
+      <p:sp>
+        <p:nvSpPr>
+          <p:cNvPr id="2" name="Title 1"/>
+          <p:cNvSpPr>
+            <a:spLocks noGrp="1"/>
+          </p:cNvSpPr>
+          <p:nvPr>
+            <p:ph type="title"/>
+          </p:nvPr>
+        </p:nvSpPr>
+        <p:spPr/>
+        <p:txBody>
+          <a:bodyPr/>
+          <a:lstStyle/>
+          <a:p>
+            <a:r>
+              <a:rPr lang="en-US" dirty="0"/>
+              <a:t>Results</a:t>
+            </a:r>
+          </a:p>
+        </p:txBody>
+      </p:sp>
+      <p:pic>
+        <p:nvPicPr>
+          <p:cNvPr id="7170" name="Picture 2"/>
+          <p:cNvPicPr>
+            <a:picLocks noGrp="1" noChangeAspect="1" noChangeArrowheads="1"/>
+          </p:cNvPicPr>
+          <p:nvPr>
+            <p:ph idx="1"/>
+          </p:nvPr>
+        </p:nvPicPr>
+        <p:blipFill rotWithShape="1">
+          <a:blip r:embed="rId2">
+            <a:extLst>
+              <a:ext uri="{BEBA8EAE-BF5A-486C-A8C5-ECC9F3942E4B}">
+                <a14:imgProps xmlns:a14="http://schemas.microsoft.com/office/drawing/2010/main">
+                  <a14:imgLayer r:embed="rId3">
+                    <a14:imgEffect>
+                      <a14:brightnessContrast contrast="40000"/>
+                    </a14:imgEffect>
+                  </a14:imgLayer>
+                </a14:imgProps>
+              </a:ext>
+              <a:ext uri="{28A0092B-C50C-407E-A947-70E740481C1C}">
+                <a14:useLocalDpi xmlns:a14="http://schemas.microsoft.com/office/drawing/2010/main" val="0"/>
+              </a:ext>
+            </a:extLst>
+          </a:blip>
+          <a:srcRect t="21315" b="-21315"/>
+          <a:stretch/>
+        </p:blipFill>
+        <p:spPr bwMode="auto">
+          <a:xfrm>
+            <a:off x="1043608" y="1196752"/>
+            <a:ext cx="7355160" cy="6721095"/>
+          </a:xfrm>
+          <a:prstGeom prst="rect">
+            <a:avLst/>
+          </a:prstGeom>
+          <a:noFill/>
+          <a:ln>
+            <a:noFill/>
+          </a:ln>
+          <a:effectLst/>
+          <a:extLst>
+            <a:ext uri="{909E8E84-426E-40DD-AFC4-6F175D3DCCD1}">
+              <a14:hiddenFill xmlns:a14="http://schemas.microsoft.com/office/drawing/2010/main">
+                <a:solidFill>
+                  <a:schemeClr val="accent1"/>
+                </a:solidFill>
+              </a14:hiddenFill>
+            </a:ext>
+            <a:ext uri="{91240B29-F687-4F45-9708-019B960494DF}">
+              <a14:hiddenLine xmlns:a14="http://schemas.microsoft.com/office/drawing/2010/main" w="9525">
+                <a:solidFill>
+                  <a:schemeClr val="tx1"/>
+                </a:solidFill>
+                <a:miter lim="800000"/>
+                <a:headEnd/>
+                <a:tailEnd/>
+              </a14:hiddenLine>
+            </a:ext>
+            <a:ext uri="{AF507438-7753-43E0-B8FC-AC1667EBCBE1}">
+              <a14:hiddenEffects xmlns:a14="http://schemas.microsoft.com/office/drawing/2010/main">
+                <a:effectLst>
+                  <a:outerShdw dist="35921" dir="2700000" algn="ctr" rotWithShape="0">
+                    <a:schemeClr val="bg2"/>
+                  </a:outerShdw>
+                </a:effectLst>
+              </a14:hiddenEffects>
+            </a:ext>
+          </a:extLst>
+        </p:spPr>
+      </p:pic>
+    </p:spTree>
+    <p:extLst>
+      <p:ext uri="{BB962C8B-B14F-4D97-AF65-F5344CB8AC3E}">
+        <p14:creationId xmlns:p14="http://schemas.microsoft.com/office/powerpoint/2010/main" val="1716557377"/>
       </p:ext>
     </p:extLst>
   </p:cSld>

</xml_diff>